<commit_message>
removes imaging lib from presentation example
</commit_message>
<xml_diff>
--- a/presentation/chart/output.pptx
+++ b/presentation/chart/output.pptx
@@ -1,6 +1,6 @@
 
 <file path=ppt/presentation.xml><?xml version="1.0" encoding="utf-8"?>
-<p:presentation xmlns="http://schemas.openxmlformats.org/presentationml/2006/main" xmlns:a="http://schemas.openxmlformats.org/drawingml/2006/main" xmlns:p="http://schemas.openxmlformats.org/presentationml/2006/main" xmlns:r="http://schemas.openxmlformats.org/officeDocument/2006/relationships" xmlns:sh="http://schemas.openxmlformats.org/officeDocument/2006/sharedTypes" xmlns:xml="http://www.w3.org/XML/1998/namespace" conformance="transitional">
+<p:presentation xmlns="http://schemas.openxmlformats.org/presentationml/2006/main" xmlns:a="http://schemas.openxmlformats.org/drawingml/2006/main" xmlns:p="http://schemas.openxmlformats.org/presentationml/2006/main" xmlns:r="http://schemas.openxmlformats.org/officeDocument/2006/relationships" xmlns:w14="http://schemas.microsoft.com/office/word/2010/wordml" xmlns:xml="http://www.w3.org/XML/1998/namespace" conformance="transitional">
   <p:sldMasterIdLst>
     <p:sldMasterId id="2147483648" r:id="rId1"/>
   </p:sldMasterIdLst>
@@ -12,7 +12,7 @@
 </file>
 
 <file path=ppt/slideLayouts/slideLayout1.xml><?xml version="1.0" encoding="utf-8"?>
-<p:sldLayout xmlns="http://schemas.openxmlformats.org/presentationml/2006/main" xmlns:a="http://schemas.openxmlformats.org/drawingml/2006/main" xmlns:p="http://schemas.openxmlformats.org/presentationml/2006/main" xmlns:r="http://schemas.openxmlformats.org/officeDocument/2006/relationships" xmlns:sh="http://schemas.openxmlformats.org/officeDocument/2006/sharedTypes" xmlns:xml="http://www.w3.org/XML/1998/namespace">
+<p:sldLayout xmlns="http://schemas.openxmlformats.org/presentationml/2006/main" xmlns:a="http://schemas.openxmlformats.org/drawingml/2006/main" xmlns:p="http://schemas.openxmlformats.org/presentationml/2006/main" xmlns:r="http://schemas.openxmlformats.org/officeDocument/2006/relationships" xmlns:w14="http://schemas.microsoft.com/office/word/2010/wordml" xmlns:xml="http://www.w3.org/XML/1998/namespace">
   <p:cSld>
     <p:spTree>
       <p:nvGrpSpPr>
@@ -27,7 +27,7 @@
 </file>
 
 <file path=ppt/slideMasters/slideMaster1.xml><?xml version="1.0" encoding="utf-8"?>
-<p:sldMaster xmlns="http://schemas.openxmlformats.org/presentationml/2006/main" xmlns:a="http://schemas.openxmlformats.org/drawingml/2006/main" xmlns:p="http://schemas.openxmlformats.org/presentationml/2006/main" xmlns:r="http://schemas.openxmlformats.org/officeDocument/2006/relationships" xmlns:sh="http://schemas.openxmlformats.org/officeDocument/2006/sharedTypes" xmlns:xml="http://www.w3.org/XML/1998/namespace">
+<p:sldMaster xmlns="http://schemas.openxmlformats.org/presentationml/2006/main" xmlns:a="http://schemas.openxmlformats.org/drawingml/2006/main" xmlns:p="http://schemas.openxmlformats.org/presentationml/2006/main" xmlns:r="http://schemas.openxmlformats.org/officeDocument/2006/relationships" xmlns:w14="http://schemas.microsoft.com/office/word/2010/wordml" xmlns:xml="http://www.w3.org/XML/1998/namespace">
   <p:cSld>
     <p:spTree>
       <p:nvGrpSpPr>
@@ -46,7 +46,7 @@
 </file>
 
 <file path=ppt/slides/slide1.xml><?xml version="1.0" encoding="utf-8"?>
-<p:sld xmlns="http://schemas.openxmlformats.org/presentationml/2006/main" xmlns:a="http://schemas.openxmlformats.org/drawingml/2006/main" xmlns:p="http://schemas.openxmlformats.org/presentationml/2006/main" xmlns:r="http://schemas.openxmlformats.org/officeDocument/2006/relationships" xmlns:sh="http://schemas.openxmlformats.org/officeDocument/2006/sharedTypes" xmlns:xml="http://www.w3.org/XML/1998/namespace">
+<p:sld xmlns="http://schemas.openxmlformats.org/presentationml/2006/main" xmlns:a="http://schemas.openxmlformats.org/drawingml/2006/main" xmlns:p="http://schemas.openxmlformats.org/presentationml/2006/main" xmlns:r="http://schemas.openxmlformats.org/officeDocument/2006/relationships" xmlns:w14="http://schemas.microsoft.com/office/word/2010/wordml" xmlns:xml="http://www.w3.org/XML/1998/namespace">
   <p:cSld>
     <p:spTree>
       <p:nvGrpSpPr>
@@ -90,7 +90,7 @@
 </file>
 
 <file path=ppt/theme/theme1.xml><?xml version="1.0" encoding="utf-8"?>
-<a:theme xmlns="http://schemas.openxmlformats.org/drawingml/2006/main" xmlns:a="http://schemas.openxmlformats.org/drawingml/2006/main" xmlns:r="http://schemas.openxmlformats.org/officeDocument/2006/relationships" xmlns:sh="http://schemas.openxmlformats.org/officeDocument/2006/sharedTypes" xmlns:xml="http://www.w3.org/XML/1998/namespace" name="unioffice Theme">
+<a:theme xmlns="http://schemas.openxmlformats.org/drawingml/2006/main" xmlns:a="http://schemas.openxmlformats.org/drawingml/2006/main" xmlns:r="http://schemas.openxmlformats.org/officeDocument/2006/relationships" xmlns:w14="http://schemas.microsoft.com/office/word/2010/wordml" xmlns:xml="http://www.w3.org/XML/1998/namespace" name="unioffice Theme">
   <a:themeElements>
     <a:clrScheme name="Office">
       <a:dk1>

</xml_diff>